<commit_message>
BP v34 (ZH + EN): final checks applied
Repeated story removed across pages (each fact has one home plus the
overview), cross-references point to the home page, wraps fixed, and the
model is named GPT 6 throughout as in the public report.

Co-Authored-By: Claude Opus 5.5 <noreply@anthropic.com>
Claude-Session: https://claude.ai/code/session_01EKqGwTA92C8Wo4e47t73NN
</commit_message>
<xml_diff>
--- a/SimReal-BP-v34-EN.pptx
+++ b/SimReal-BP-v34-EN.pptx
@@ -6448,7 +6448,7 @@
                 <a:cs typeface="Instrument Sans"/>
                 <a:sym typeface="Instrument Sans"/>
               </a:rPr>
-              <a:t>Custom tasks, held-out days, reward API; own or licensed data with a license chain</a:t>
+              <a:t>Custom tasks, held-out days, reward API; data with a license chain</a:t>
             </a:r>
           </a:p>
         </p:txBody>
@@ -6728,7 +6728,7 @@
                 <a:cs typeface="Instrument Sans"/>
                 <a:sym typeface="Instrument Sans"/>
               </a:rPr>
-              <a:t>Full environments, matching engine, counterparty models, reserve tasks, trajectories, expert data</a:t>
+              <a:t>Full environments, matching engine, counterparty models, reserve tasks, expert data</a:t>
             </a:r>
           </a:p>
         </p:txBody>
@@ -7187,7 +7187,7 @@
                 <a:cs typeface="Instrument Sans"/>
                 <a:sym typeface="Instrument Sans"/>
               </a:rPr>
-              <a:t>Unit economics (est.): a public environment takes about 6 person-days; a second lab reuses the same environment. Buyer concentration: license each environment to many labs and to trading firms.</a:t>
+              <a:t>Unit economics (est.): a public environment takes about 6 person-days; from the second lab on, it is reused as is. Buyer concentration: extend to trading firms.</a:t>
             </a:r>
           </a:p>
         </p:txBody>
@@ -10744,7 +10744,7 @@
                 <a:cs typeface="IBM Plex Mono"/>
                 <a:sym typeface="IBM Plex Mono"/>
               </a:rPr>
-              <a:t>③ Three live domains · per year (est.)</a:t>
+              <a:t>③ If 2 more domains match finance (est.)</a:t>
             </a:r>
           </a:p>
         </p:txBody>
@@ -10975,7 +10975,7 @@
                 <a:cs typeface="Instrument Sans"/>
                 <a:sym typeface="Instrument Sans"/>
               </a:rPr>
-              <a:t>× Event prediction, AI research</a:t>
+              <a:t>Trading + prediction + AI research</a:t>
             </a:r>
           </a:p>
         </p:txBody>
@@ -11236,22 +11236,7 @@
                 <a:cs typeface="Instrument Sans"/>
                 <a:sym typeface="Instrument Sans"/>
               </a:rPr>
-              <a:t>(Deedy Das, Jul 2026)</a:t>
-            </a:r>
-            <a:br>
-              <a:rPr lang="en-US" sz="950"/>
-            </a:br>
-            <a:r>
-              <a:rPr lang="en-US" sz="950" b="0" i="0" u="none" strike="noStrike" cap="none">
-                <a:solidFill>
-                  <a:srgbClr val="E27A3F"/>
-                </a:solidFill>
-                <a:latin typeface="Instrument Sans"/>
-                <a:ea typeface="Instrument Sans"/>
-                <a:cs typeface="Instrument Sans"/>
-                <a:sym typeface="Instrument Sans"/>
-              </a:rPr>
-              <a:t>Finance is only the first domain</a:t>
+              <a:t>Source: Deedy Das, Jul 2026</a:t>
             </a:r>
           </a:p>
         </p:txBody>
@@ -11281,7 +11266,7 @@
           </a:bodyPr>
           <a:lstStyle/>
           <a:p>
-            <a:pPr marL="0" marR="0" lvl="0" indent="0" algn="ctr" rtl="0">
+            <a:pPr marL="0" marR="0" lvl="0" indent="0" algn="l" rtl="0">
               <a:spcBef>
                 <a:spcPts val="0"/>
               </a:spcBef>
@@ -11312,7 +11297,7 @@
                 <a:cs typeface="Newsreader"/>
                 <a:sym typeface="Newsreader"/>
               </a:rPr>
-              <a:t>each new scorable domain multiplies it</a:t>
+              <a:t>each new scorable domain adds another</a:t>
             </a:r>
             <a:r>
               <a:rPr lang="en-US" sz="1800" b="0" i="0" u="none" strike="noStrike" cap="none">
@@ -11402,7 +11387,7 @@
                 <a:cs typeface="Instrument Sans"/>
                 <a:sym typeface="Instrument Sans"/>
               </a:rPr>
-              <a:t>Estimates: finance priced at the upper-middle (task floor ~$500, per Mechanize’s ~$2,400 of training compute per task); volume per lab, tier counts (China benchmarked to UniPat orders) and the three-domain extrapolation are our assumptions.</a:t>
+              <a:t>Estimates: finance priced at the upper-middle (task floor ~$500, per Mechanize’s ~$2,400 of training compute per task); volume per lab (China benchmarked to UniPat orders), tier counts and the three-domain extrapolation are our assumptions.</a:t>
             </a:r>
           </a:p>
           <a:p>
@@ -13225,7 +13210,7 @@
                 <a:cs typeface="Instrument Sans"/>
                 <a:sym typeface="Instrument Sans"/>
               </a:rPr>
-              <a:t>One environment for evals and training: eval data, agent trajectories and iterative training, delivered together</a:t>
+              <a:t>One environment for evals and training: Qwen3.8-27B up to 12% better after training (page 6)</a:t>
             </a:r>
           </a:p>
         </p:txBody>
@@ -13355,7 +13340,7 @@
                 <a:cs typeface="Instrument Sans"/>
                 <a:sym typeface="Instrument Sans"/>
               </a:rPr>
-              <a:t>Matching and scoring on our own engine; reserve tasks and unpublished held-out days; 7 environments live</a:t>
+              <a:t>Matching and scoring on our own engine; a 7,000+ expert waitlist (page 8)</a:t>
             </a:r>
           </a:p>
         </p:txBody>
@@ -14292,7 +14277,7 @@
                 <a:cs typeface="Instrument Sans"/>
                 <a:sym typeface="Instrument Sans"/>
               </a:rPr>
-              <a:t>Score = max(0, P&amp;L − 0.1×DD) × Sharpe factor</a:t>
+              <a:t>A = max(0, P&amp;L − 0.1×DD) × Sharpe factor</a:t>
             </a:r>
           </a:p>
           <a:p>
@@ -14370,7 +14355,7 @@
                 <a:cs typeface="Instrument Sans"/>
                 <a:sym typeface="Instrument Sans"/>
               </a:rPr>
-              <a:t>return and risk diverge, so risk is priced in</a:t>
+              <a:t>return and risk diverge; the reward counts both</a:t>
             </a:r>
           </a:p>
         </p:txBody>
@@ -14708,7 +14693,7 @@
                 <a:cs typeface="Instrument Sans"/>
                 <a:sym typeface="Instrument Sans"/>
               </a:rPr>
-              <a:t>Jane Street, Citadel, Optiver (quant);</a:t>
+              <a:t>All three founders have quant-firm experience (page 3);</a:t>
             </a:r>
           </a:p>
           <a:p>
@@ -14734,7 +14719,7 @@
                 <a:cs typeface="Instrument Sans"/>
                 <a:sym typeface="Instrument Sans"/>
               </a:rPr>
-              <a:t>Millennium data science; Cambridge, LSE, Duke math</a:t>
+              <a:t>the team designed the three rules above</a:t>
             </a:r>
           </a:p>
         </p:txBody>
@@ -14864,7 +14849,33 @@
                 <a:cs typeface="Instrument Sans"/>
                 <a:sym typeface="Instrument Sans"/>
               </a:rPr>
-              <a:t>Labs choosing environments keep citing one key test: no high score by gaming (Epoch AI, 18 interviews)</a:t>
+              <a:t>Interviewees repeatedly name it a key quality test: no high score by gaming</a:t>
+            </a:r>
+          </a:p>
+          <a:p>
+            <a:pPr marL="0" marR="0" lvl="0" indent="0" algn="l" rtl="0">
+              <a:lnSpc>
+                <a:spcPct val="110000"/>
+              </a:lnSpc>
+              <a:spcBef>
+                <a:spcPts val="0"/>
+              </a:spcBef>
+              <a:spcAft>
+                <a:spcPts val="0"/>
+              </a:spcAft>
+              <a:buNone/>
+            </a:pPr>
+            <a:r>
+              <a:rPr lang="en-US" sz="1000" b="0" i="0" u="none" strike="noStrike" cap="none">
+                <a:solidFill>
+                  <a:srgbClr val="33322F"/>
+                </a:solidFill>
+                <a:latin typeface="Instrument Sans"/>
+                <a:ea typeface="Instrument Sans"/>
+                <a:cs typeface="Instrument Sans"/>
+                <a:sym typeface="Instrument Sans"/>
+              </a:rPr>
+              <a:t>Epoch AI, 18 interviews</a:t>
             </a:r>
           </a:p>
         </p:txBody>
@@ -16075,7 +16086,7 @@
         <p:spPr>
           <a:xfrm>
             <a:off x="548640" y="2286000"/>
-            <a:ext cx="5408676" cy="2560320"/>
+            <a:ext cx="5408676" cy="2670048"/>
           </a:xfrm>
           <a:prstGeom prst="rect">
             <a:avLst/>
@@ -16770,7 +16781,7 @@
         <p:spPr>
           <a:xfrm>
             <a:off x="822960" y="4443984"/>
-            <a:ext cx="1510284" cy="384048"/>
+            <a:ext cx="1510284" cy="457200"/>
           </a:xfrm>
           <a:prstGeom prst="rect">
             <a:avLst/>
@@ -16871,7 +16882,7 @@
         <p:spPr>
           <a:xfrm>
             <a:off x="2442972" y="4443984"/>
-            <a:ext cx="1510284" cy="384048"/>
+            <a:ext cx="1510284" cy="457200"/>
           </a:xfrm>
           <a:prstGeom prst="rect">
             <a:avLst/>
@@ -16972,7 +16983,7 @@
         <p:spPr>
           <a:xfrm>
             <a:off x="4062984" y="4443984"/>
-            <a:ext cx="1510284" cy="384048"/>
+            <a:ext cx="1510284" cy="457200"/>
           </a:xfrm>
           <a:prstGeom prst="rect">
             <a:avLst/>
@@ -17010,7 +17021,33 @@
                 <a:cs typeface="Newsreader"/>
                 <a:sym typeface="Newsreader"/>
               </a:rPr>
-              <a:t>2–3 paying labs, $1M–$3M ARR</a:t>
+              <a:t>2–3 paying labs</a:t>
+            </a:r>
+          </a:p>
+          <a:p>
+            <a:pPr marL="0" marR="0" lvl="0" indent="0" algn="l" rtl="0">
+              <a:lnSpc>
+                <a:spcPct val="105000"/>
+              </a:lnSpc>
+              <a:spcBef>
+                <a:spcPts val="0"/>
+              </a:spcBef>
+              <a:spcAft>
+                <a:spcPts val="0"/>
+              </a:spcAft>
+              <a:buNone/>
+            </a:pPr>
+            <a:r>
+              <a:rPr lang="en-US" sz="1000" b="0" i="0" u="none" strike="noStrike" cap="none">
+                <a:solidFill>
+                  <a:srgbClr val="111110"/>
+                </a:solidFill>
+                <a:latin typeface="Newsreader"/>
+                <a:ea typeface="Newsreader"/>
+                <a:cs typeface="Newsreader"/>
+                <a:sym typeface="Newsreader"/>
+              </a:rPr>
+              <a:t>$1M–$3M ARR</a:t>
             </a:r>
           </a:p>
         </p:txBody>
@@ -17024,7 +17061,7 @@
         <p:spPr>
           <a:xfrm>
             <a:off x="6231636" y="2286000"/>
-            <a:ext cx="5408676" cy="2560320"/>
+            <a:ext cx="5408676" cy="2670048"/>
           </a:xfrm>
           <a:prstGeom prst="rect">
             <a:avLst/>
@@ -17621,7 +17658,7 @@
         <p:spPr>
           <a:xfrm>
             <a:off x="6505956" y="4443984"/>
-            <a:ext cx="1510284" cy="384048"/>
+            <a:ext cx="1510284" cy="457200"/>
           </a:xfrm>
           <a:prstGeom prst="rect">
             <a:avLst/>
@@ -17722,7 +17759,7 @@
         <p:spPr>
           <a:xfrm>
             <a:off x="8125968" y="4443984"/>
-            <a:ext cx="1510284" cy="384048"/>
+            <a:ext cx="1510284" cy="457200"/>
           </a:xfrm>
           <a:prstGeom prst="rect">
             <a:avLst/>
@@ -17823,7 +17860,7 @@
         <p:spPr>
           <a:xfrm>
             <a:off x="9745980" y="4443984"/>
-            <a:ext cx="1510284" cy="384048"/>
+            <a:ext cx="1510284" cy="457200"/>
           </a:xfrm>
           <a:prstGeom prst="rect">
             <a:avLst/>
@@ -17874,7 +17911,7 @@
         </p:nvSpPr>
         <p:spPr>
           <a:xfrm>
-            <a:off x="548640" y="4919472"/>
+            <a:off x="548640" y="5047488"/>
             <a:ext cx="8229600" cy="201168"/>
           </a:xfrm>
           <a:prstGeom prst="rect">
@@ -17923,7 +17960,7 @@
         </p:nvSpPr>
         <p:spPr>
           <a:xfrm>
-            <a:off x="548640" y="5138928"/>
+            <a:off x="548640" y="5266944"/>
             <a:ext cx="2601468" cy="548640"/>
           </a:xfrm>
           <a:prstGeom prst="rect">
@@ -17952,7 +17989,7 @@
         </p:nvSpPr>
         <p:spPr>
           <a:xfrm>
-            <a:off x="731520" y="5157216"/>
+            <a:off x="731520" y="5285232"/>
             <a:ext cx="2327148" cy="292608"/>
           </a:xfrm>
           <a:prstGeom prst="rect">
@@ -18013,7 +18050,7 @@
         </p:nvSpPr>
         <p:spPr>
           <a:xfrm>
-            <a:off x="731520" y="5449824"/>
+            <a:off x="731520" y="5577840"/>
             <a:ext cx="2327148" cy="201168"/>
           </a:xfrm>
           <a:prstGeom prst="rect">
@@ -18062,7 +18099,7 @@
         </p:nvSpPr>
         <p:spPr>
           <a:xfrm>
-            <a:off x="3378708" y="5138928"/>
+            <a:off x="3378708" y="5266944"/>
             <a:ext cx="2601468" cy="548640"/>
           </a:xfrm>
           <a:prstGeom prst="rect">
@@ -18091,7 +18128,7 @@
         </p:nvSpPr>
         <p:spPr>
           <a:xfrm>
-            <a:off x="3561588" y="5157216"/>
+            <a:off x="3561588" y="5285232"/>
             <a:ext cx="2327148" cy="292608"/>
           </a:xfrm>
           <a:prstGeom prst="rect">
@@ -18152,7 +18189,7 @@
         </p:nvSpPr>
         <p:spPr>
           <a:xfrm>
-            <a:off x="3561588" y="5449824"/>
+            <a:off x="3561588" y="5577840"/>
             <a:ext cx="2327148" cy="201168"/>
           </a:xfrm>
           <a:prstGeom prst="rect">
@@ -18201,7 +18238,7 @@
         </p:nvSpPr>
         <p:spPr>
           <a:xfrm>
-            <a:off x="6208776" y="5138928"/>
+            <a:off x="6208776" y="5266944"/>
             <a:ext cx="2601468" cy="548640"/>
           </a:xfrm>
           <a:prstGeom prst="rect">
@@ -18230,7 +18267,7 @@
         </p:nvSpPr>
         <p:spPr>
           <a:xfrm>
-            <a:off x="6391656" y="5157216"/>
+            <a:off x="6391656" y="5285232"/>
             <a:ext cx="2327148" cy="292608"/>
           </a:xfrm>
           <a:prstGeom prst="rect">
@@ -18291,7 +18328,7 @@
         </p:nvSpPr>
         <p:spPr>
           <a:xfrm>
-            <a:off x="6391656" y="5449824"/>
+            <a:off x="6391656" y="5577840"/>
             <a:ext cx="2327148" cy="201168"/>
           </a:xfrm>
           <a:prstGeom prst="rect">
@@ -18340,7 +18377,7 @@
         </p:nvSpPr>
         <p:spPr>
           <a:xfrm>
-            <a:off x="9038844" y="5138928"/>
+            <a:off x="9038844" y="5266944"/>
             <a:ext cx="2601468" cy="548640"/>
           </a:xfrm>
           <a:prstGeom prst="rect">
@@ -18369,7 +18406,7 @@
         </p:nvSpPr>
         <p:spPr>
           <a:xfrm>
-            <a:off x="9221724" y="5157216"/>
+            <a:off x="9221724" y="5285232"/>
             <a:ext cx="2327148" cy="292608"/>
           </a:xfrm>
           <a:prstGeom prst="rect">
@@ -18430,7 +18467,7 @@
         </p:nvSpPr>
         <p:spPr>
           <a:xfrm>
-            <a:off x="9221724" y="5449824"/>
+            <a:off x="9221724" y="5577840"/>
             <a:ext cx="2327148" cy="201168"/>
           </a:xfrm>
           <a:prstGeom prst="rect">
@@ -18479,7 +18516,7 @@
         </p:nvSpPr>
         <p:spPr>
           <a:xfrm>
-            <a:off x="548640" y="5742432"/>
+            <a:off x="548640" y="5870448"/>
             <a:ext cx="11091672" cy="274320"/>
           </a:xfrm>
           <a:prstGeom prst="rect">
@@ -19627,7 +19664,7 @@
                 <a:cs typeface="Instrument Sans"/>
                 <a:sym typeface="Instrument Sans"/>
               </a:rPr>
-              <a:t>Professional work like trading, made scorable</a:t>
+              <a:t>Starting with trading: order books, simulator scoring</a:t>
             </a:r>
           </a:p>
           <a:p>
@@ -28792,7 +28829,7 @@
                 <a:cs typeface="Instrument Sans"/>
                 <a:sym typeface="Instrument Sans"/>
               </a:rPr>
-              <a:t>RSI: recursive self-improvement, where AI helps improve the next AI and each round’s real outcomes become the next round’s training data</a:t>
+              <a:t>RSI: recursive self-improvement, where AI helps improve the next AI</a:t>
             </a:r>
           </a:p>
         </p:txBody>
@@ -29408,7 +29445,7 @@
                 <a:cs typeface="Instrument Sans"/>
                 <a:sym typeface="Instrument Sans"/>
               </a:rPr>
-              <a:t>Gets historical order books and product rules, researches for 6 or 12 hours with sandboxed tools, writes Trader.run(state); submissions are final</a:t>
+              <a:t>Researches the order books for 6 or 12 hours with sandboxed tools, writes Trader.run(state); no resubmits</a:t>
             </a:r>
           </a:p>
         </p:txBody>
@@ -29538,7 +29575,7 @@
                 <a:cs typeface="Instrument Sans"/>
                 <a:sym typeface="Instrument Sans"/>
               </a:rPr>
-              <a:t>Replays IMC Prosperity order books tick by tick; each fill is attributed to the book at order time</a:t>
+              <a:t>Replays IMC Prosperity order books tick by tick (matching rules on page 12)</a:t>
             </a:r>
           </a:p>
         </p:txBody>
@@ -30903,8 +30940,8 @@
         </p:nvSpPr>
         <p:spPr>
           <a:xfrm>
-            <a:off x="548640" y="4974336"/>
-            <a:ext cx="11091672" cy="365760"/>
+            <a:off x="548640" y="5047488"/>
+            <a:ext cx="11091672" cy="292608"/>
           </a:xfrm>
           <a:prstGeom prst="rect">
             <a:avLst/>
@@ -31538,7 +31575,7 @@
                 <a:cs typeface="Newsreader"/>
                 <a:sym typeface="Newsreader"/>
               </a:rPr>
-              <a:t>7 benchmarks and environments in 14 days, 5 public repos; </a:t>
+              <a:t>7 benchmarks and environments, from trading to software; </a:t>
             </a:r>
             <a:r>
               <a:rPr lang="en-US" sz="1600" b="0" i="0" u="none" strike="noStrike" cap="none">
@@ -31550,7 +31587,7 @@
                 <a:cs typeface="Newsreader"/>
                 <a:sym typeface="Newsreader"/>
               </a:rPr>
-              <a:t>no outside funding</a:t>
+              <a:t>5 open-sourced</a:t>
             </a:r>
           </a:p>
         </p:txBody>
@@ -31974,7 +32011,7 @@
                 <a:cs typeface="Instrument Sans"/>
                 <a:sym typeface="Instrument Sans"/>
               </a:rPr>
-              <a:t>Replays competition order books; scores P&amp;L, drawdown, Sharpe; training loop run</a:t>
+              <a:t>Flagship market-making environment (page 6)</a:t>
             </a:r>
           </a:p>
         </p:txBody>
@@ -33949,7 +33986,7 @@
                 <a:cs typeface="Instrument Sans"/>
                 <a:sym typeface="Instrument Sans"/>
               </a:rPr>
-              <a:t>Demonstrations, judgments and scoring standards from real work, entry roles to top research</a:t>
+              <a:t>Demonstrations, judgments and scoring standards from real work, via our expert network (page 8)</a:t>
             </a:r>
           </a:p>
         </p:txBody>
@@ -34128,7 +34165,7 @@
                 <a:cs typeface="Instrument Sans"/>
                 <a:sym typeface="Instrument Sans"/>
               </a:rPr>
-              <a:t>Private eval and held-out sets, never used in training; red-teamed before release</a:t>
+              <a:t>Private eval and held-out sets: for testing only, never for training; red-teamed</a:t>
             </a:r>
           </a:p>
         </p:txBody>

</xml_diff>